<commit_message>
docs(pitch): rebuild the deck for the Robinhood Chain track, funding shown as shares
</commit_message>
<xml_diff>
--- a/docs/pitch/CargoFlow-pitch.pptx
+++ b/docs/pitch/CargoFlow-pitch.pptx
@@ -1402,7 +1402,7 @@
           <a:p>
             <a:r>
               <a:rPr lang="en-US" dirty="0"/>
-              <a:t>Our ask is the buildathon's milestone grant of up to 30,000 USDG, split across M1 to M4. Thirty-five percent goes to the security audit and ZK ceremony, 25 to pilots and logger hardware, 20 to the mainnet launch and first facilities, and 10 each to legal and to infrastructure. We propose releasing it the way CargoFlow releases capital: each tranche against a milestone's exit test.</a:t>
+              <a:t>Our ask is funding released milestone by milestone, whether it comes as prize money, an accelerator or seed capital. We show shares, not amounts, because the size of the round is not ours to set. Thirty-five percent goes to the security audit and the public ZK ceremony, 25 to pilots and logger hardware, 20 to the mainnet launch and first facilities, and 10 each to legal and to infrastructure. We propose releasing it the way CargoFlow releases capital: each tranche follows a milestone's exit test.</a:t>
             </a:r>
             <a:endParaRPr lang="en-US" dirty="0"/>
           </a:p>
@@ -1578,7 +1578,7 @@
           <a:p>
             <a:r>
               <a:rPr lang="en-US" dirty="0"/>
-              <a:t>Against the buildathon's criteria: every core contract is deployed and verified on Robinhood Chain Testnet, the contract suite has 366 tests including eight invariants, and the product has portals for every party plus four published packages. USDG is the only money CargoFlow moves, and Robinhood Chain's P-256 precompile carries the passkey flow. Each line links to evidence in the README.</a:t>
+              <a:t>Here is what is live on the Robinhood Chain track: every core contract is deployed and verified on Robinhood Chain Testnet, USDG is the only money CargoFlow moves, and the chain's P-256 precompile carries the passkey flow. On Arbitrum Sepolia there are the Stylus, Fhenix and GMX extensions. The contract suite has 366 tests including eight invariants, and the product has portals for every party plus four published packages. Every claim links to something you can click.</a:t>
             </a:r>
             <a:endParaRPr lang="en-US" dirty="0"/>
           </a:p>
@@ -3043,7 +3043,7 @@
                 <a:ea typeface="Inter" pitchFamily="34" charset="-122"/>
                 <a:cs typeface="Inter" pitchFamily="34" charset="-120"/>
               </a:rPr>
-              <a:t>Arbitrum Open House Singapore · Online Buildathon · October 2026</a:t>
+              <a:t>Colosseum Crypto World's Fair · Robinhood Chain track · October 2026</a:t>
             </a:r>
             <a:endParaRPr lang="en-US" sz="1400" dirty="0"/>
           </a:p>
@@ -14055,7 +14055,7 @@
                 <a:ea typeface="JetBrains Mono" pitchFamily="34" charset="-122"/>
                 <a:cs typeface="JetBrains Mono" pitchFamily="34" charset="-120"/>
               </a:rPr>
-              <a:t>35% OF GRANT</a:t>
+              <a:t>35% OF FUNDING</a:t>
             </a:r>
             <a:endParaRPr lang="en-US" sz="1200" dirty="0"/>
           </a:p>
@@ -14272,7 +14272,7 @@
                 <a:ea typeface="JetBrains Mono" pitchFamily="34" charset="-122"/>
                 <a:cs typeface="JetBrains Mono" pitchFamily="34" charset="-120"/>
               </a:rPr>
-              <a:t>25% OF GRANT</a:t>
+              <a:t>25% OF FUNDING</a:t>
             </a:r>
             <a:endParaRPr lang="en-US" sz="1200" dirty="0"/>
           </a:p>
@@ -14489,7 +14489,7 @@
                 <a:ea typeface="JetBrains Mono" pitchFamily="34" charset="-122"/>
                 <a:cs typeface="JetBrains Mono" pitchFamily="34" charset="-120"/>
               </a:rPr>
-              <a:t>20% OF GRANT</a:t>
+              <a:t>20% OF FUNDING</a:t>
             </a:r>
             <a:endParaRPr lang="en-US" sz="1200" dirty="0"/>
           </a:p>
@@ -14706,7 +14706,7 @@
                 <a:ea typeface="JetBrains Mono" pitchFamily="34" charset="-122"/>
                 <a:cs typeface="JetBrains Mono" pitchFamily="34" charset="-120"/>
               </a:rPr>
-              <a:t>10% OF GRANT</a:t>
+              <a:t>10% OF FUNDING</a:t>
             </a:r>
             <a:endParaRPr lang="en-US" sz="1200" dirty="0"/>
           </a:p>
@@ -14923,7 +14923,7 @@
                 <a:ea typeface="JetBrains Mono" pitchFamily="34" charset="-122"/>
                 <a:cs typeface="JetBrains Mono" pitchFamily="34" charset="-120"/>
               </a:rPr>
-              <a:t>AFTER THE GRANT</a:t>
+              <a:t>AFTER THIS ROUND</a:t>
             </a:r>
             <a:endParaRPr lang="en-US" sz="1200" dirty="0"/>
           </a:p>
@@ -15153,7 +15153,7 @@
                 <a:ea typeface="JetBrains Mono" pitchFamily="34" charset="-122"/>
                 <a:cs typeface="JetBrains Mono" pitchFamily="34" charset="-120"/>
               </a:rPr>
-              <a:t>THE ASK: THE MILESTONE-BASED GRANT</a:t>
+              <a:t>THE ASK: MILESTONE-RELEASED FUNDING</a:t>
             </a:r>
             <a:endParaRPr lang="en-US" sz="1200" dirty="0"/>
           </a:p>
@@ -15195,7 +15195,7 @@
                 <a:ea typeface="Space Grotesk" pitchFamily="34" charset="-122"/>
                 <a:cs typeface="Space Grotesk" pitchFamily="34" charset="-120"/>
               </a:rPr>
-              <a:t>A 30,000 USDG grant funds </a:t>
+              <a:t>Prize and seed money fund </a:t>
             </a:r>
             <a:pPr algn="l" indent="0" marL="0">
               <a:lnSpc>
@@ -15707,7 +15707,7 @@
                 <a:ea typeface="JetBrains Mono" pitchFamily="34" charset="-122"/>
                 <a:cs typeface="JetBrains Mono" pitchFamily="34" charset="-120"/>
               </a:rPr>
-              <a:t>10,500 USDG</a:t>
+              <a:t>35% of funds</a:t>
             </a:r>
             <a:endParaRPr lang="en-US" sz="1600" dirty="0"/>
           </a:p>
@@ -15883,7 +15883,7 @@
                 <a:ea typeface="JetBrains Mono" pitchFamily="34" charset="-122"/>
                 <a:cs typeface="JetBrains Mono" pitchFamily="34" charset="-120"/>
               </a:rPr>
-              <a:t>7,500 USDG</a:t>
+              <a:t>25% of funds</a:t>
             </a:r>
             <a:endParaRPr lang="en-US" sz="1600" dirty="0"/>
           </a:p>
@@ -16059,7 +16059,7 @@
                 <a:ea typeface="JetBrains Mono" pitchFamily="34" charset="-122"/>
                 <a:cs typeface="JetBrains Mono" pitchFamily="34" charset="-120"/>
               </a:rPr>
-              <a:t>6,000 USDG</a:t>
+              <a:t>20% of funds</a:t>
             </a:r>
             <a:endParaRPr lang="en-US" sz="1600" dirty="0"/>
           </a:p>
@@ -16235,7 +16235,7 @@
                 <a:ea typeface="JetBrains Mono" pitchFamily="34" charset="-122"/>
                 <a:cs typeface="JetBrains Mono" pitchFamily="34" charset="-120"/>
               </a:rPr>
-              <a:t>3,000 USDG</a:t>
+              <a:t>10% of funds</a:t>
             </a:r>
             <a:endParaRPr lang="en-US" sz="1600" dirty="0"/>
           </a:p>
@@ -16411,7 +16411,7 @@
                 <a:ea typeface="JetBrains Mono" pitchFamily="34" charset="-122"/>
                 <a:cs typeface="JetBrains Mono" pitchFamily="34" charset="-120"/>
               </a:rPr>
-              <a:t>3,000 USDG</a:t>
+              <a:t>10% of funds</a:t>
             </a:r>
             <a:endParaRPr lang="en-US" sz="1600" dirty="0"/>
           </a:p>
@@ -16495,7 +16495,7 @@
                 <a:ea typeface="Inter" pitchFamily="34" charset="-122"/>
                 <a:cs typeface="Inter" pitchFamily="34" charset="-120"/>
               </a:rPr>
-              <a:t>Arbitrum Open House Singapore Online Buildathon (HackQuest): 115,000 USDG in prizes, including up to 30,000 USDG in milestone-based grants · any prize follows the same split</a:t>
+              <a:t>A plan, not a commitment: shares of whatever the round provides, whether prize, accelerator or seed money · figures are percentages on purpose</a:t>
             </a:r>
             <a:endParaRPr lang="en-US" sz="1100" dirty="0"/>
           </a:p>
@@ -17111,7 +17111,7 @@
                 <a:ea typeface="JetBrains Mono" pitchFamily="34" charset="-122"/>
                 <a:cs typeface="JetBrains Mono" pitchFamily="34" charset="-120"/>
               </a:rPr>
-              <a:t>20 · BUILDATHON FIT</a:t>
+              <a:t>20 · TRACK FIT</a:t>
             </a:r>
             <a:endParaRPr lang="en-US" sz="1100" dirty="0"/>
           </a:p>
@@ -17153,7 +17153,7 @@
                 <a:ea typeface="JetBrains Mono" pitchFamily="34" charset="-122"/>
                 <a:cs typeface="JetBrains Mono" pitchFamily="34" charset="-120"/>
               </a:rPr>
-              <a:t>ARBITRUM OPEN HOUSE SINGAPORE</a:t>
+              <a:t>THE ROBINHOOD CHAIN TRACK</a:t>
             </a:r>
             <a:endParaRPr lang="en-US" sz="1200" dirty="0"/>
           </a:p>
@@ -17195,7 +17195,7 @@
                 <a:ea typeface="Space Grotesk" pitchFamily="34" charset="-122"/>
                 <a:cs typeface="Space Grotesk" pitchFamily="34" charset="-120"/>
               </a:rPr>
-              <a:t>Every criterion, with </a:t>
+              <a:t>What is live, with </a:t>
             </a:r>
             <a:pPr algn="l" indent="0" marL="0">
               <a:lnSpc>
@@ -17298,7 +17298,7 @@
                 <a:ea typeface="Space Grotesk" pitchFamily="34" charset="-122"/>
                 <a:cs typeface="Space Grotesk" pitchFamily="34" charset="-120"/>
               </a:rPr>
-              <a:t>Deployed on an Arbitrum chain</a:t>
+              <a:t>Robinhood Chain</a:t>
             </a:r>
             <a:endParaRPr lang="en-US" sz="1600" dirty="0"/>
           </a:p>
@@ -17404,7 +17404,7 @@
                 <a:ea typeface="Space Grotesk" pitchFamily="34" charset="-122"/>
                 <a:cs typeface="Space Grotesk" pitchFamily="34" charset="-120"/>
               </a:rPr>
-              <a:t>Smart contract quality</a:t>
+              <a:t>Chain features</a:t>
             </a:r>
             <a:endParaRPr lang="en-US" sz="1600" dirty="0"/>
           </a:p>
@@ -17446,7 +17446,7 @@
                 <a:ea typeface="Inter" pitchFamily="34" charset="-122"/>
                 <a:cs typeface="Inter" pitchFamily="34" charset="-120"/>
               </a:rPr>
-              <a:t>366 tests, eight invariants, an immutable core with no proxy.</a:t>
+              <a:t>Its RIP-7212 precompile carries the passkey flow.</a:t>
             </a:r>
             <a:endParaRPr lang="en-US" sz="1400" dirty="0"/>
           </a:p>
@@ -17510,7 +17510,7 @@
                 <a:ea typeface="Space Grotesk" pitchFamily="34" charset="-122"/>
                 <a:cs typeface="Space Grotesk" pitchFamily="34" charset="-120"/>
               </a:rPr>
-              <a:t>Product-market fit</a:t>
+              <a:t>Paxos USDG</a:t>
             </a:r>
             <a:endParaRPr lang="en-US" sz="1600" dirty="0"/>
           </a:p>
@@ -17552,7 +17552,7 @@
                 <a:ea typeface="Inter" pitchFamily="34" charset="-122"/>
                 <a:cs typeface="Inter" pitchFamily="34" charset="-120"/>
               </a:rPr>
-              <a:t>A sourced problem, five role portals, four published packages.</a:t>
+              <a:t>The only money CargoFlow moves.</a:t>
             </a:r>
             <a:endParaRPr lang="en-US" sz="1400" dirty="0"/>
           </a:p>
@@ -17616,7 +17616,7 @@
                 <a:ea typeface="Space Grotesk" pitchFamily="34" charset="-122"/>
                 <a:cs typeface="Space Grotesk" pitchFamily="34" charset="-120"/>
               </a:rPr>
-              <a:t>Innovation</a:t>
+              <a:t>Arbitrum</a:t>
             </a:r>
             <a:endParaRPr lang="en-US" sz="1600" dirty="0"/>
           </a:p>
@@ -17658,7 +17658,7 @@
                 <a:ea typeface="Inter" pitchFamily="34" charset="-122"/>
                 <a:cs typeface="Inter" pitchFamily="34" charset="-120"/>
               </a:rPr>
-              <a:t>Evidence-gated capital, bound ZK recovery, a keyless Claude co-pilot.</a:t>
+              <a:t>Stylus, Fhenix and GMX on Arbitrum Sepolia.</a:t>
             </a:r>
             <a:endParaRPr lang="en-US" sz="1400" dirty="0"/>
           </a:p>
@@ -17722,7 +17722,7 @@
                 <a:ea typeface="Space Grotesk" pitchFamily="34" charset="-122"/>
                 <a:cs typeface="Space Grotesk" pitchFamily="34" charset="-120"/>
               </a:rPr>
-              <a:t>Real problem solving</a:t>
+              <a:t>Working product</a:t>
             </a:r>
             <a:endParaRPr lang="en-US" sz="1600" dirty="0"/>
           </a:p>
@@ -17764,7 +17764,7 @@
                 <a:ea typeface="Inter" pitchFamily="34" charset="-122"/>
                 <a:cs typeface="Inter" pitchFamily="34" charset="-120"/>
               </a:rPr>
-              <a:t>End-to-end runs with every transaction linked.</a:t>
+              <a:t>Five portals, an API, an MCP server, four packages.</a:t>
             </a:r>
             <a:endParaRPr lang="en-US" sz="1400" dirty="0"/>
           </a:p>
@@ -17828,7 +17828,7 @@
                 <a:ea typeface="Space Grotesk" pitchFamily="34" charset="-122"/>
                 <a:cs typeface="Space Grotesk" pitchFamily="34" charset="-120"/>
               </a:rPr>
-              <a:t>Paxos USDG</a:t>
+              <a:t>Contract quality</a:t>
             </a:r>
             <a:endParaRPr lang="en-US" sz="1600" dirty="0"/>
           </a:p>
@@ -17870,7 +17870,7 @@
                 <a:ea typeface="Inter" pitchFamily="34" charset="-122"/>
                 <a:cs typeface="Inter" pitchFamily="34" charset="-120"/>
               </a:rPr>
-              <a:t>The only money CargoFlow moves.</a:t>
+              <a:t>366 tests, eight invariants, an immutable core with no proxy.</a:t>
             </a:r>
             <a:endParaRPr lang="en-US" sz="1400" dirty="0"/>
           </a:p>
@@ -17934,7 +17934,7 @@
                 <a:ea typeface="Space Grotesk" pitchFamily="34" charset="-122"/>
                 <a:cs typeface="Space Grotesk" pitchFamily="34" charset="-120"/>
               </a:rPr>
-              <a:t>Robinhood Chain</a:t>
+              <a:t>Real runs</a:t>
             </a:r>
             <a:endParaRPr lang="en-US" sz="1600" dirty="0"/>
           </a:p>
@@ -17976,7 +17976,7 @@
                 <a:ea typeface="Inter" pitchFamily="34" charset="-122"/>
                 <a:cs typeface="Inter" pitchFamily="34" charset="-120"/>
               </a:rPr>
-              <a:t>Its RIP-7212 precompile carries the passkey flow.</a:t>
+              <a:t>End-to-end runs with every transaction linked.</a:t>
             </a:r>
             <a:endParaRPr lang="en-US" sz="1400" dirty="0"/>
           </a:p>
@@ -18017,7 +18017,7 @@
                 <a:latin typeface="Inter" pitchFamily="34" charset="0"/>
                 <a:ea typeface="Inter" pitchFamily="34" charset="-122"/>
                 <a:cs typeface="Inter" pitchFamily="34" charset="-120"/>
-                <a:hlinkClick r:id="rId2" invalidUrl="" action="" tgtFrame="" tooltip="https://www.hackquest.io/hackathons/Arbitrum-Open-House-Singapore-Online-Buildathon" history="1" highlightClick="0" endSnd="0">
+                <a:hlinkClick r:id="rId2" invalidUrl="" action="" tgtFrame="" tooltip="https://blog.colosseum.com/expanding-the-arena/" history="1" highlightClick="0" endSnd="0">
                   <a:extLst>
                     <a:ext uri="{A12FA001-AC4F-418D-AE19-62706E023703}">
                       <ahyp:hlinkClr xmlns:ahyp="http://schemas.microsoft.com/office/drawing/2018/hyperlinkcolor" val="tx"/>
@@ -18025,7 +18025,7 @@
                   </a:extLst>
                 </a:hlinkClick>
               </a:rPr>
-              <a:t>Read the HackQuest listing</a:t>
+              <a:t>Read the Crypto World's Fair announcement</a:t>
             </a:r>
             <a:endParaRPr lang="en-US" sz="1400" dirty="0"/>
           </a:p>
@@ -18067,7 +18067,7 @@
                 <a:ea typeface="Inter" pitchFamily="34" charset="-122"/>
                 <a:cs typeface="Inter" pitchFamily="34" charset="-120"/>
               </a:rPr>
-              <a:t>Evidence: README "Built for Arbitrum Open House Singapore", "Live on Robinhood Chain Testnet", "Measured, not claimed" · docs/project/21-hackathon-alignment.md</a:t>
+              <a:t>Evidence: README "Built on Robinhood Chain", "Live on Robinhood Chain Testnet", "Measured, not claimed" · docs/project/21-hackathon-alignment.md</a:t>
             </a:r>
             <a:endParaRPr lang="en-US" sz="1100" dirty="0"/>
           </a:p>

</xml_diff>